<commit_message>
Add CNN version, CNN vs MLP comparison slides, Windows Japanese fonts
- CUDA/src/cudacnn.cu: CNN engine (conv/pool/relu/fc, im2col + gemm,
  same source on GPU (CUDA + cuBLAS) and CPU (OpenMP + OpenBLAS), FP64/FP32)
- cudacnn.l, nn-cnn.l: layer-list network description, training and
  benchmark functions (test-mnist-cnn, bench-mnist-cnn)
- docs/mnist_cnn.pptx: CNN with/without comparison (accuracy, time,
  backpropagation, kernel updates, LeNet, parameter effects, glossary)
- docs/*.pptx: switch fonts to BIZ UDPGothic / BIZ UDGothic (available on Windows)
- README.md: CNN usage

Co-Authored-By: Claude Opus 5.5 <noreply@anthropic.com>
Claude-Session: https://claude.ai/code/session_01FpW9rzwRJSY3uez546qSr8
</commit_message>
<xml_diff>
--- a/docs/mnist_cuda.pptx
+++ b/docs/mnist_cuda.pptx
@@ -130,20 +130,20 @@
   <p:extLst>
     <p:ext uri="{521415D9-36F7-43E2-AB2F-B90AF26B5E84}">
       <p14:sectionLst xmlns:p14="http://schemas.microsoft.com/office/powerpoint/2010/main">
-        <p14:section name="タイトル" id="{0821d84e-9845-f7e0-54b9-717dcce6366b}">
+        <p14:section name="タイトル" id="{8371baec-ea44-dbaf-5d42-8e827fdfd355}">
           <p14:sldIdLst>
             <p14:sldId id="256"/>
             <p14:sldId id="257"/>
           </p14:sldIdLst>
         </p14:section>
-        <p14:section name="1. どこを GPU に移すか" id="{f20b708f-9501-9ec3-ad39-2be1f66485a8}">
+        <p14:section name="1. どこを GPU に移すか" id="{bb1c4772-8b96-a6a3-c3da-9a2e5957a9a4}">
           <p14:sldIdLst>
             <p14:sldId id="258"/>
             <p14:sldId id="259"/>
             <p14:sldId id="260"/>
           </p14:sldIdLst>
         </p14:section>
-        <p14:section name="2. 接続方法の候補" id="{5a0ca3c5-15c6-8ca5-72d7-f391fb162e89}">
+        <p14:section name="2. 接続方法の候補" id="{03a599d5-e7b6-9817-077f-d4c344f95f5c}">
           <p14:sldIdLst>
             <p14:sldId id="261"/>
             <p14:sldId id="262"/>
@@ -154,7 +154,7 @@
             <p14:sldId id="267"/>
           </p14:sldIdLst>
         </p14:section>
-        <p14:section name="3. 速度の比較" id="{48d350b1-886e-f90a-5c76-1c0faba717e1}">
+        <p14:section name="3. 速度の比較" id="{ee55cc72-ca27-11a6-45a0-87046e426e9a}">
           <p14:sldIdLst>
             <p14:sldId id="268"/>
             <p14:sldId id="269"/>
@@ -164,7 +164,7 @@
             <p14:sldId id="273"/>
           </p14:sldIdLst>
         </p14:section>
-        <p14:section name="4. 結果の正しさ" id="{afe2e471-6f6c-3891-827e-00c52c4dd987}">
+        <p14:section name="4. 結果の正しさ" id="{77bc2e5a-7fcc-aadf-e986-a3f111212e8f}">
           <p14:sldIdLst>
             <p14:sldId id="274"/>
             <p14:sldId id="275"/>
@@ -172,7 +172,7 @@
             <p14:sldId id="277"/>
           </p14:sldIdLst>
         </p14:section>
-        <p14:section name="5. まとめ" id="{1aa72567-c59f-9dbb-33cd-e40663b7a209}">
+        <p14:section name="5. まとめ" id="{8a84b65f-64de-a956-faaa-ce83b0b31c40}">
           <p14:sldIdLst>
             <p14:sldId id="278"/>
             <p14:sldId id="279"/>
@@ -279,6 +279,7 @@
                         <a:srgbClr val="FFFFFF"/>
                       </a:solidFill>
                       <a:latin typeface="+mn-lt"/>
+                      <a:ea typeface="BIZ UDPGothic"/>
                     </a:defRPr>
                   </a:pPr>
                 </a:p>
@@ -304,6 +305,7 @@
                         <a:srgbClr val="FFFFFF"/>
                       </a:solidFill>
                       <a:latin typeface="+mn-lt"/>
+                      <a:ea typeface="BIZ UDPGothic"/>
                     </a:defRPr>
                   </a:pPr>
                 </a:p>
@@ -329,6 +331,7 @@
                         <a:srgbClr val="FFFFFF"/>
                       </a:solidFill>
                       <a:latin typeface="+mn-lt"/>
+                      <a:ea typeface="BIZ UDPGothic"/>
                     </a:defRPr>
                   </a:pPr>
                 </a:p>
@@ -354,6 +357,7 @@
                         <a:srgbClr val="FFFFFF"/>
                       </a:solidFill>
                       <a:latin typeface="+mn-lt"/>
+                      <a:ea typeface="BIZ UDPGothic"/>
                     </a:defRPr>
                   </a:pPr>
                 </a:p>
@@ -375,7 +379,8 @@
                     <a:solidFill>
                       <a:srgbClr val="000000"/>
                     </a:solidFill>
-                    <a:latin typeface="Arial"/>
+                    <a:latin typeface="BIZ UDPGothic"/>
+                    <a:ea typeface="BIZ UDPGothic"/>
                   </a:defRPr>
                 </a:pPr>
               </a:p>
@@ -450,6 +455,7 @@
           <a:pPr>
             <a:defRPr sz="1100">
               <a:latin typeface="+mn-lt"/>
+              <a:ea typeface="BIZ UDPGothic"/>
               <a:cs typeface="+mn-lt"/>
             </a:defRPr>
           </a:pPr>
@@ -490,6 +496,7 @@
                   <a:srgbClr val="14213D"/>
                 </a:solidFill>
                 <a:latin typeface="+mn-lt"/>
+                <a:ea typeface="BIZ UDPGothic"/>
               </a:defRPr>
             </a:pPr>
             <a:r>
@@ -498,6 +505,7 @@
                   <a:srgbClr val="14213D"/>
                 </a:solidFill>
                 <a:latin typeface="+mn-lt"/>
+                <a:ea typeface="BIZ UDPGothic"/>
               </a:rPr>
               <a:t>1 回あたり [ms]（小さいほど速い）</a:t>
             </a:r>
@@ -547,6 +555,7 @@
                       <a:srgbClr val="14213D"/>
                     </a:solidFill>
                     <a:latin typeface="+mn-lt"/>
+                    <a:ea typeface="BIZ UDPGothic"/>
                   </a:defRPr>
                 </a:pPr>
               </a:p>
@@ -633,6 +642,7 @@
                       <a:srgbClr val="14213D"/>
                     </a:solidFill>
                     <a:latin typeface="+mn-lt"/>
+                    <a:ea typeface="BIZ UDPGothic"/>
                   </a:defRPr>
                 </a:pPr>
               </a:p>
@@ -719,6 +729,7 @@
                       <a:srgbClr val="14213D"/>
                     </a:solidFill>
                     <a:latin typeface="+mn-lt"/>
+                    <a:ea typeface="BIZ UDPGothic"/>
                   </a:defRPr>
                 </a:pPr>
               </a:p>
@@ -805,6 +816,7 @@
                       <a:srgbClr val="14213D"/>
                     </a:solidFill>
                     <a:latin typeface="+mn-lt"/>
+                    <a:ea typeface="BIZ UDPGothic"/>
                   </a:defRPr>
                 </a:pPr>
               </a:p>
@@ -891,6 +903,7 @@
                       <a:srgbClr val="14213D"/>
                     </a:solidFill>
                     <a:latin typeface="+mn-lt"/>
+                    <a:ea typeface="BIZ UDPGothic"/>
                   </a:defRPr>
                 </a:pPr>
               </a:p>
@@ -956,6 +969,7 @@
                     <a:srgbClr val="14213D"/>
                   </a:solidFill>
                   <a:latin typeface="+mn-lt"/>
+                  <a:ea typeface="BIZ UDPGothic"/>
                 </a:defRPr>
               </a:pPr>
             </a:p>
@@ -1004,6 +1018,7 @@
                   <a:srgbClr val="5B6577"/>
                 </a:solidFill>
                 <a:latin typeface="+mn-lt"/>
+                <a:ea typeface="BIZ UDPGothic"/>
               </a:defRPr>
             </a:pPr>
             <a:endParaRPr lang="en-US"/>
@@ -1045,6 +1060,7 @@
                   <a:srgbClr val="5B6577"/>
                 </a:solidFill>
                 <a:latin typeface="+mn-lt"/>
+                <a:ea typeface="BIZ UDPGothic"/>
               </a:defRPr>
             </a:pPr>
             <a:endParaRPr lang="en-US"/>
@@ -1072,6 +1088,7 @@
           <a:pPr>
             <a:defRPr sz="1100">
               <a:latin typeface="+mn-lt"/>
+              <a:ea typeface="BIZ UDPGothic"/>
               <a:cs typeface="+mn-lt"/>
             </a:defRPr>
           </a:pPr>
@@ -1112,6 +1129,7 @@
                   <a:srgbClr val="14213D"/>
                 </a:solidFill>
                 <a:latin typeface="+mn-lt"/>
+                <a:ea typeface="BIZ UDPGothic"/>
               </a:defRPr>
             </a:pPr>
             <a:r>
@@ -1120,6 +1138,7 @@
                   <a:srgbClr val="14213D"/>
                 </a:solidFill>
                 <a:latin typeface="+mn-lt"/>
+                <a:ea typeface="BIZ UDPGothic"/>
               </a:rPr>
               <a:t>1 エポック（300 バッチ）の壁時計時間 [s]</a:t>
             </a:r>
@@ -1169,6 +1188,7 @@
                       <a:srgbClr val="14213D"/>
                     </a:solidFill>
                     <a:latin typeface="+mn-lt"/>
+                    <a:ea typeface="BIZ UDPGothic"/>
                   </a:defRPr>
                 </a:pPr>
               </a:p>
@@ -1298,6 +1318,7 @@
                     <a:srgbClr val="14213D"/>
                   </a:solidFill>
                   <a:latin typeface="+mn-lt"/>
+                  <a:ea typeface="BIZ UDPGothic"/>
                 </a:defRPr>
               </a:pPr>
             </a:p>
@@ -1346,6 +1367,7 @@
                   <a:srgbClr val="5B6577"/>
                 </a:solidFill>
                 <a:latin typeface="+mn-lt"/>
+                <a:ea typeface="BIZ UDPGothic"/>
               </a:defRPr>
             </a:pPr>
             <a:endParaRPr lang="en-US"/>
@@ -1387,6 +1409,7 @@
                   <a:srgbClr val="5B6577"/>
                 </a:solidFill>
                 <a:latin typeface="+mn-lt"/>
+                <a:ea typeface="BIZ UDPGothic"/>
               </a:defRPr>
             </a:pPr>
             <a:endParaRPr lang="en-US"/>
@@ -1470,6 +1493,7 @@
                       <a:srgbClr val="000000"/>
                     </a:solidFill>
                     <a:latin typeface="+mn-lt"/>
+                    <a:ea typeface="BIZ UDPGothic"/>
                   </a:defRPr>
                 </a:pPr>
               </a:p>
@@ -1590,6 +1614,7 @@
                       <a:srgbClr val="000000"/>
                     </a:solidFill>
                     <a:latin typeface="+mn-lt"/>
+                    <a:ea typeface="BIZ UDPGothic"/>
                   </a:defRPr>
                 </a:pPr>
               </a:p>
@@ -1710,6 +1735,7 @@
                       <a:srgbClr val="000000"/>
                     </a:solidFill>
                     <a:latin typeface="+mn-lt"/>
+                    <a:ea typeface="BIZ UDPGothic"/>
                   </a:defRPr>
                 </a:pPr>
               </a:p>
@@ -1802,6 +1828,7 @@
                     <a:srgbClr val="000000"/>
                   </a:solidFill>
                   <a:latin typeface="+mn-lt"/>
+                  <a:ea typeface="BIZ UDPGothic"/>
                 </a:defRPr>
               </a:pPr>
             </a:p>
@@ -1837,7 +1864,8 @@
                     <a:solidFill>
                       <a:srgbClr val="5B6577"/>
                     </a:solidFill>
-                    <a:latin typeface="Arial"/>
+                    <a:latin typeface="BIZ UDPGothic"/>
+                    <a:ea typeface="BIZ UDPGothic"/>
                   </a:defRPr>
                 </a:pPr>
                 <a:r>
@@ -1845,7 +1873,8 @@
                     <a:solidFill>
                       <a:srgbClr val="5B6577"/>
                     </a:solidFill>
-                    <a:latin typeface="Arial"/>
+                    <a:latin typeface="BIZ UDPGothic"/>
+                    <a:ea typeface="BIZ UDPGothic"/>
                   </a:rPr>
                   <a:t>バッチサイズ</a:t>
                 </a:r>
@@ -1878,6 +1907,7 @@
                   <a:srgbClr val="5B6577"/>
                 </a:solidFill>
                 <a:latin typeface="+mn-lt"/>
+                <a:ea typeface="BIZ UDPGothic"/>
               </a:defRPr>
             </a:pPr>
             <a:endParaRPr lang="en-US"/>
@@ -1921,7 +1951,8 @@
                     <a:solidFill>
                       <a:srgbClr val="5B6577"/>
                     </a:solidFill>
-                    <a:latin typeface="Arial"/>
+                    <a:latin typeface="BIZ UDPGothic"/>
+                    <a:ea typeface="BIZ UDPGothic"/>
                   </a:defRPr>
                 </a:pPr>
                 <a:r>
@@ -1929,7 +1960,8 @@
                     <a:solidFill>
                       <a:srgbClr val="5B6577"/>
                     </a:solidFill>
-                    <a:latin typeface="Arial"/>
+                    <a:latin typeface="BIZ UDPGothic"/>
+                    <a:ea typeface="BIZ UDPGothic"/>
                   </a:rPr>
                   <a:t>1エポック [s]（対数）</a:t>
                 </a:r>
@@ -1962,6 +1994,7 @@
                   <a:srgbClr val="5B6577"/>
                 </a:solidFill>
                 <a:latin typeface="+mn-lt"/>
+                <a:ea typeface="BIZ UDPGothic"/>
               </a:defRPr>
             </a:pPr>
             <a:endParaRPr lang="en-US"/>
@@ -1989,6 +2022,7 @@
           <a:pPr>
             <a:defRPr sz="1200">
               <a:latin typeface="+mn-lt"/>
+              <a:ea typeface="BIZ UDPGothic"/>
               <a:cs typeface="+mn-lt"/>
             </a:defRPr>
           </a:pPr>
@@ -2062,6 +2096,7 @@
                       <a:srgbClr val="000000"/>
                     </a:solidFill>
                     <a:latin typeface="+mn-lt"/>
+                    <a:ea typeface="BIZ UDPGothic"/>
                   </a:defRPr>
                 </a:pPr>
               </a:p>
@@ -2272,6 +2307,7 @@
                       <a:srgbClr val="000000"/>
                     </a:solidFill>
                     <a:latin typeface="+mn-lt"/>
+                    <a:ea typeface="BIZ UDPGothic"/>
                   </a:defRPr>
                 </a:pPr>
               </a:p>
@@ -2482,6 +2518,7 @@
                       <a:srgbClr val="000000"/>
                     </a:solidFill>
                     <a:latin typeface="+mn-lt"/>
+                    <a:ea typeface="BIZ UDPGothic"/>
                   </a:defRPr>
                 </a:pPr>
               </a:p>
@@ -2692,6 +2729,7 @@
                       <a:srgbClr val="000000"/>
                     </a:solidFill>
                     <a:latin typeface="+mn-lt"/>
+                    <a:ea typeface="BIZ UDPGothic"/>
                   </a:defRPr>
                 </a:pPr>
               </a:p>
@@ -2874,6 +2912,7 @@
                     <a:srgbClr val="000000"/>
                   </a:solidFill>
                   <a:latin typeface="+mn-lt"/>
+                  <a:ea typeface="BIZ UDPGothic"/>
                 </a:defRPr>
               </a:pPr>
             </a:p>
@@ -2909,7 +2948,8 @@
                     <a:solidFill>
                       <a:srgbClr val="5B6577"/>
                     </a:solidFill>
-                    <a:latin typeface="Arial"/>
+                    <a:latin typeface="BIZ UDPGothic"/>
+                    <a:ea typeface="BIZ UDPGothic"/>
                   </a:defRPr>
                 </a:pPr>
                 <a:r>
@@ -2917,7 +2957,8 @@
                     <a:solidFill>
                       <a:srgbClr val="5B6577"/>
                     </a:solidFill>
-                    <a:latin typeface="Arial"/>
+                    <a:latin typeface="BIZ UDPGothic"/>
+                    <a:ea typeface="BIZ UDPGothic"/>
                   </a:rPr>
                   <a:t>エポック</a:t>
                 </a:r>
@@ -2950,6 +2991,7 @@
                   <a:srgbClr val="5B6577"/>
                 </a:solidFill>
                 <a:latin typeface="+mn-lt"/>
+                <a:ea typeface="BIZ UDPGothic"/>
               </a:defRPr>
             </a:pPr>
             <a:endParaRPr lang="en-US"/>
@@ -2992,7 +3034,8 @@
                     <a:solidFill>
                       <a:srgbClr val="5B6577"/>
                     </a:solidFill>
-                    <a:latin typeface="Arial"/>
+                    <a:latin typeface="BIZ UDPGothic"/>
+                    <a:ea typeface="BIZ UDPGothic"/>
                   </a:defRPr>
                 </a:pPr>
                 <a:r>
@@ -3000,7 +3043,8 @@
                     <a:solidFill>
                       <a:srgbClr val="5B6577"/>
                     </a:solidFill>
-                    <a:latin typeface="Arial"/>
+                    <a:latin typeface="BIZ UDPGothic"/>
+                    <a:ea typeface="BIZ UDPGothic"/>
                   </a:rPr>
                   <a:t>テスト認識率 [%]</a:t>
                 </a:r>
@@ -3033,6 +3077,7 @@
                   <a:srgbClr val="5B6577"/>
                 </a:solidFill>
                 <a:latin typeface="+mn-lt"/>
+                <a:ea typeface="BIZ UDPGothic"/>
               </a:defRPr>
             </a:pPr>
             <a:endParaRPr lang="en-US"/>
@@ -3061,6 +3106,7 @@
           <a:pPr>
             <a:defRPr sz="1100">
               <a:latin typeface="+mn-lt"/>
+              <a:ea typeface="BIZ UDPGothic"/>
               <a:cs typeface="+mn-lt"/>
             </a:defRPr>
           </a:pPr>
@@ -3101,6 +3147,7 @@
                   <a:srgbClr val="14213D"/>
                 </a:solidFill>
                 <a:latin typeface="+mn-lt"/>
+                <a:ea typeface="BIZ UDPGothic"/>
               </a:defRPr>
             </a:pPr>
             <a:r>
@@ -3109,6 +3156,7 @@
                   <a:srgbClr val="14213D"/>
                 </a:solidFill>
                 <a:latin typeface="+mn-lt"/>
+                <a:ea typeface="BIZ UDPGothic"/>
               </a:rPr>
               <a:t>行列積の実効性能 [TFLOPS]</a:t>
             </a:r>
@@ -3158,6 +3206,7 @@
                       <a:srgbClr val="14213D"/>
                     </a:solidFill>
                     <a:latin typeface="+mn-lt"/>
+                    <a:ea typeface="BIZ UDPGothic"/>
                   </a:defRPr>
                 </a:pPr>
               </a:p>
@@ -3271,6 +3320,7 @@
                     <a:srgbClr val="14213D"/>
                   </a:solidFill>
                   <a:latin typeface="+mn-lt"/>
+                  <a:ea typeface="BIZ UDPGothic"/>
                 </a:defRPr>
               </a:pPr>
             </a:p>
@@ -3319,6 +3369,7 @@
                   <a:srgbClr val="5B6577"/>
                 </a:solidFill>
                 <a:latin typeface="+mn-lt"/>
+                <a:ea typeface="BIZ UDPGothic"/>
               </a:defRPr>
             </a:pPr>
             <a:endParaRPr lang="en-US"/>
@@ -3360,6 +3411,7 @@
                   <a:srgbClr val="5B6577"/>
                 </a:solidFill>
                 <a:latin typeface="+mn-lt"/>
+                <a:ea typeface="BIZ UDPGothic"/>
               </a:defRPr>
             </a:pPr>
             <a:endParaRPr lang="en-US"/>
@@ -7019,9 +7071,9 @@
                 <a:solidFill>
                   <a:srgbClr val="E8ECF3"/>
                 </a:solidFill>
-                <a:latin typeface="Noto Sans Mono CJK JP" pitchFamily="34" charset="0"/>
-                <a:ea typeface="Noto Sans Mono CJK JP" pitchFamily="34" charset="-122"/>
-                <a:cs typeface="Noto Sans Mono CJK JP" pitchFamily="34" charset="-120"/>
+                <a:latin typeface="BIZ UDGothic" pitchFamily="34" charset="0"/>
+                <a:ea typeface="BIZ UDGothic" pitchFamily="34" charset="-122"/>
+                <a:cs typeface="BIZ UDGothic" pitchFamily="34" charset="-120"/>
               </a:rPr>
               <a:t>(setq *cublas-lib* (load-foreign "/usr/local/cuda/lib64/libcublas.so"))</a:t>
             </a:r>
@@ -7036,9 +7088,9 @@
                 <a:solidFill>
                   <a:srgbClr val="E8ECF3"/>
                 </a:solidFill>
-                <a:latin typeface="Noto Sans Mono CJK JP" pitchFamily="34" charset="0"/>
-                <a:ea typeface="Noto Sans Mono CJK JP" pitchFamily="34" charset="-122"/>
-                <a:cs typeface="Noto Sans Mono CJK JP" pitchFamily="34" charset="-120"/>
+                <a:latin typeface="BIZ UDGothic" pitchFamily="34" charset="0"/>
+                <a:ea typeface="BIZ UDGothic" pitchFamily="34" charset="-122"/>
+                <a:cs typeface="BIZ UDGothic" pitchFamily="34" charset="-120"/>
               </a:rPr>
               <a:t>(defforeign cudaMalloc *cudart-lib* "cudaMalloc" () :integer)</a:t>
             </a:r>
@@ -7053,9 +7105,9 @@
                 <a:solidFill>
                   <a:srgbClr val="E8ECF3"/>
                 </a:solidFill>
-                <a:latin typeface="Noto Sans Mono CJK JP" pitchFamily="34" charset="0"/>
-                <a:ea typeface="Noto Sans Mono CJK JP" pitchFamily="34" charset="-122"/>
-                <a:cs typeface="Noto Sans Mono CJK JP" pitchFamily="34" charset="-120"/>
+                <a:latin typeface="BIZ UDGothic" pitchFamily="34" charset="0"/>
+                <a:ea typeface="BIZ UDGothic" pitchFamily="34" charset="-122"/>
+                <a:cs typeface="BIZ UDGothic" pitchFamily="34" charset="-120"/>
               </a:rPr>
               <a:t>(defforeign cublasDgemm_v2 *cublas-lib* "cublasDgemm_v2" () :integer)</a:t>
             </a:r>
@@ -7076,9 +7128,9 @@
                 <a:solidFill>
                   <a:srgbClr val="E8ECF3"/>
                 </a:solidFill>
-                <a:latin typeface="Noto Sans Mono CJK JP" pitchFamily="34" charset="0"/>
-                <a:ea typeface="Noto Sans Mono CJK JP" pitchFamily="34" charset="-122"/>
-                <a:cs typeface="Noto Sans Mono CJK JP" pitchFamily="34" charset="-120"/>
+                <a:latin typeface="BIZ UDGothic" pitchFamily="34" charset="0"/>
+                <a:ea typeface="BIZ UDGothic" pitchFamily="34" charset="-122"/>
+                <a:cs typeface="BIZ UDGothic" pitchFamily="34" charset="-120"/>
               </a:rPr>
               <a:t>;; GPU のアドレスは integer-vector に書いてもらい整数で持つ</a:t>
             </a:r>
@@ -7093,9 +7145,9 @@
                 <a:solidFill>
                   <a:srgbClr val="E8ECF3"/>
                 </a:solidFill>
-                <a:latin typeface="Noto Sans Mono CJK JP" pitchFamily="34" charset="0"/>
-                <a:ea typeface="Noto Sans Mono CJK JP" pitchFamily="34" charset="-122"/>
-                <a:cs typeface="Noto Sans Mono CJK JP" pitchFamily="34" charset="-120"/>
+                <a:latin typeface="BIZ UDGothic" pitchFamily="34" charset="0"/>
+                <a:ea typeface="BIZ UDGothic" pitchFamily="34" charset="-122"/>
+                <a:cs typeface="BIZ UDGothic" pitchFamily="34" charset="-120"/>
               </a:rPr>
               <a:t>(let ((p (integer-vector 0)))</a:t>
             </a:r>
@@ -7110,9 +7162,9 @@
                 <a:solidFill>
                   <a:srgbClr val="E8ECF3"/>
                 </a:solidFill>
-                <a:latin typeface="Noto Sans Mono CJK JP" pitchFamily="34" charset="0"/>
-                <a:ea typeface="Noto Sans Mono CJK JP" pitchFamily="34" charset="-122"/>
-                <a:cs typeface="Noto Sans Mono CJK JP" pitchFamily="34" charset="-120"/>
+                <a:latin typeface="BIZ UDGothic" pitchFamily="34" charset="0"/>
+                <a:ea typeface="BIZ UDGothic" pitchFamily="34" charset="-122"/>
+                <a:cs typeface="BIZ UDGothic" pitchFamily="34" charset="-120"/>
               </a:rPr>
               <a:t>  (cudaMalloc p (* 8 nelem)) (elt p 0))</a:t>
             </a:r>
@@ -7133,9 +7185,9 @@
                 <a:solidFill>
                   <a:srgbClr val="E8ECF3"/>
                 </a:solidFill>
-                <a:latin typeface="Noto Sans Mono CJK JP" pitchFamily="34" charset="0"/>
-                <a:ea typeface="Noto Sans Mono CJK JP" pitchFamily="34" charset="-122"/>
-                <a:cs typeface="Noto Sans Mono CJK JP" pitchFamily="34" charset="-120"/>
+                <a:latin typeface="BIZ UDGothic" pitchFamily="34" charset="0"/>
+                <a:ea typeface="BIZ UDGothic" pitchFamily="34" charset="-122"/>
+                <a:cs typeface="BIZ UDGothic" pitchFamily="34" charset="-120"/>
               </a:rPr>
               <a:t>;; cuBLAS v2 は alpha, beta をポインタで受ける -&gt; float-vector</a:t>
             </a:r>
@@ -7150,9 +7202,9 @@
                 <a:solidFill>
                   <a:srgbClr val="E8ECF3"/>
                 </a:solidFill>
-                <a:latin typeface="Noto Sans Mono CJK JP" pitchFamily="34" charset="0"/>
-                <a:ea typeface="Noto Sans Mono CJK JP" pitchFamily="34" charset="-122"/>
-                <a:cs typeface="Noto Sans Mono CJK JP" pitchFamily="34" charset="-120"/>
+                <a:latin typeface="BIZ UDGothic" pitchFamily="34" charset="0"/>
+                <a:ea typeface="BIZ UDGothic" pitchFamily="34" charset="-122"/>
+                <a:cs typeface="BIZ UDGothic" pitchFamily="34" charset="-120"/>
               </a:rPr>
               <a:t>(cudaMemcpy da (a . entity) (* 8 m k) 1)   ; host -&gt; device</a:t>
             </a:r>
@@ -7167,9 +7219,9 @@
                 <a:solidFill>
                   <a:srgbClr val="E8ECF3"/>
                 </a:solidFill>
-                <a:latin typeface="Noto Sans Mono CJK JP" pitchFamily="34" charset="0"/>
-                <a:ea typeface="Noto Sans Mono CJK JP" pitchFamily="34" charset="-122"/>
-                <a:cs typeface="Noto Sans Mono CJK JP" pitchFamily="34" charset="-120"/>
+                <a:latin typeface="BIZ UDGothic" pitchFamily="34" charset="0"/>
+                <a:ea typeface="BIZ UDGothic" pitchFamily="34" charset="-122"/>
+                <a:cs typeface="BIZ UDGothic" pitchFamily="34" charset="-120"/>
               </a:rPr>
               <a:t>(cublasDgemm_v2 handle 0 0 n m k (float-vector alpha)</a:t>
             </a:r>
@@ -7184,9 +7236,9 @@
                 <a:solidFill>
                   <a:srgbClr val="E8ECF3"/>
                 </a:solidFill>
-                <a:latin typeface="Noto Sans Mono CJK JP" pitchFamily="34" charset="0"/>
-                <a:ea typeface="Noto Sans Mono CJK JP" pitchFamily="34" charset="-122"/>
-                <a:cs typeface="Noto Sans Mono CJK JP" pitchFamily="34" charset="-120"/>
+                <a:latin typeface="BIZ UDGothic" pitchFamily="34" charset="0"/>
+                <a:ea typeface="BIZ UDGothic" pitchFamily="34" charset="-122"/>
+                <a:cs typeface="BIZ UDGothic" pitchFamily="34" charset="-120"/>
               </a:rPr>
               <a:t>                db n da k (float-vector beta) dc n)</a:t>
             </a:r>
@@ -7201,9 +7253,9 @@
                 <a:solidFill>
                   <a:srgbClr val="E8ECF3"/>
                 </a:solidFill>
-                <a:latin typeface="Noto Sans Mono CJK JP" pitchFamily="34" charset="0"/>
-                <a:ea typeface="Noto Sans Mono CJK JP" pitchFamily="34" charset="-122"/>
-                <a:cs typeface="Noto Sans Mono CJK JP" pitchFamily="34" charset="-120"/>
+                <a:latin typeface="BIZ UDGothic" pitchFamily="34" charset="0"/>
+                <a:ea typeface="BIZ UDGothic" pitchFamily="34" charset="-122"/>
+                <a:cs typeface="BIZ UDGothic" pitchFamily="34" charset="-120"/>
               </a:rPr>
               <a:t>(cudaMemcpy (c . entity) dc (* 8 m n) 2)   ; device -&gt; host</a:t>
             </a:r>
@@ -7620,9 +7672,9 @@
                 <a:solidFill>
                   <a:srgbClr val="E8ECF3"/>
                 </a:solidFill>
-                <a:latin typeface="Noto Sans Mono CJK JP" pitchFamily="34" charset="0"/>
-                <a:ea typeface="Noto Sans Mono CJK JP" pitchFamily="34" charset="-122"/>
-                <a:cs typeface="Noto Sans Mono CJK JP" pitchFamily="34" charset="-120"/>
+                <a:latin typeface="BIZ UDGothic" pitchFamily="34" charset="0"/>
+                <a:ea typeface="BIZ UDGothic" pitchFamily="34" charset="-122"/>
+                <a:cs typeface="BIZ UDGothic" pitchFamily="34" charset="-120"/>
               </a:rPr>
               <a:t>(setq *ipc* (piped-fork "python3" "ipc/torch_server.py"))</a:t>
             </a:r>
@@ -7643,9 +7695,9 @@
                 <a:solidFill>
                   <a:srgbClr val="E8ECF3"/>
                 </a:solidFill>
-                <a:latin typeface="Noto Sans Mono CJK JP" pitchFamily="34" charset="0"/>
-                <a:ea typeface="Noto Sans Mono CJK JP" pitchFamily="34" charset="-122"/>
-                <a:cs typeface="Noto Sans Mono CJK JP" pitchFamily="34" charset="-120"/>
+                <a:latin typeface="BIZ UDGothic" pitchFamily="34" charset="0"/>
+                <a:ea typeface="BIZ UDGothic" pitchFamily="34" charset="-122"/>
+                <a:cs typeface="BIZ UDGothic" pitchFamily="34" charset="-120"/>
               </a:rPr>
               <a:t>(defun fv-bytes (v)   ; float-vector をコピーせずバイト列に</a:t>
             </a:r>
@@ -7660,9 +7712,9 @@
                 <a:solidFill>
                   <a:srgbClr val="E8ECF3"/>
                 </a:solidFill>
-                <a:latin typeface="Noto Sans Mono CJK JP" pitchFamily="34" charset="0"/>
-                <a:ea typeface="Noto Sans Mono CJK JP" pitchFamily="34" charset="-122"/>
-                <a:cs typeface="Noto Sans Mono CJK JP" pitchFamily="34" charset="-120"/>
+                <a:latin typeface="BIZ UDGothic" pitchFamily="34" charset="0"/>
+                <a:ea typeface="BIZ UDGothic" pitchFamily="34" charset="-122"/>
+                <a:cs typeface="BIZ UDGothic" pitchFamily="34" charset="-120"/>
               </a:rPr>
               <a:t>  (make-foreign-string (+ (sys:address v) 16) (* 8 (length v))))</a:t>
             </a:r>
@@ -7683,9 +7735,9 @@
                 <a:solidFill>
                   <a:srgbClr val="E8ECF3"/>
                 </a:solidFill>
-                <a:latin typeface="Noto Sans Mono CJK JP" pitchFamily="34" charset="0"/>
-                <a:ea typeface="Noto Sans Mono CJK JP" pitchFamily="34" charset="-122"/>
-                <a:cs typeface="Noto Sans Mono CJK JP" pitchFamily="34" charset="-120"/>
+                <a:latin typeface="BIZ UDGothic" pitchFamily="34" charset="0"/>
+                <a:ea typeface="BIZ UDGothic" pitchFamily="34" charset="-122"/>
+                <a:cs typeface="BIZ UDGothic" pitchFamily="34" charset="-120"/>
               </a:rPr>
               <a:t>(defun ipc-dgemm (a b c &amp;optional (alpha 1.0) (beta 1.0))</a:t>
             </a:r>
@@ -7700,9 +7752,9 @@
                 <a:solidFill>
                   <a:srgbClr val="E8ECF3"/>
                 </a:solidFill>
-                <a:latin typeface="Noto Sans Mono CJK JP" pitchFamily="34" charset="0"/>
-                <a:ea typeface="Noto Sans Mono CJK JP" pitchFamily="34" charset="-122"/>
-                <a:cs typeface="Noto Sans Mono CJK JP" pitchFamily="34" charset="-120"/>
+                <a:latin typeface="BIZ UDGothic" pitchFamily="34" charset="0"/>
+                <a:ea typeface="BIZ UDGothic" pitchFamily="34" charset="-122"/>
+                <a:cs typeface="BIZ UDGothic" pitchFamily="34" charset="-120"/>
               </a:rPr>
               <a:t>  (ipc-send-header 1 m n k 1)      ; int64 x 8</a:t>
             </a:r>
@@ -7717,9 +7769,9 @@
                 <a:solidFill>
                   <a:srgbClr val="E8ECF3"/>
                 </a:solidFill>
-                <a:latin typeface="Noto Sans Mono CJK JP" pitchFamily="34" charset="0"/>
-                <a:ea typeface="Noto Sans Mono CJK JP" pitchFamily="34" charset="-122"/>
-                <a:cs typeface="Noto Sans Mono CJK JP" pitchFamily="34" charset="-120"/>
+                <a:latin typeface="BIZ UDGothic" pitchFamily="34" charset="0"/>
+                <a:ea typeface="BIZ UDGothic" pitchFamily="34" charset="-122"/>
+                <a:cs typeface="BIZ UDGothic" pitchFamily="34" charset="-120"/>
               </a:rPr>
               <a:t>  (ipc-write (a . entity)) (ipc-write (b . entity))</a:t>
             </a:r>
@@ -7734,9 +7786,9 @@
                 <a:solidFill>
                   <a:srgbClr val="E8ECF3"/>
                 </a:solidFill>
-                <a:latin typeface="Noto Sans Mono CJK JP" pitchFamily="34" charset="0"/>
-                <a:ea typeface="Noto Sans Mono CJK JP" pitchFamily="34" charset="-122"/>
-                <a:cs typeface="Noto Sans Mono CJK JP" pitchFamily="34" charset="-120"/>
+                <a:latin typeface="BIZ UDGothic" pitchFamily="34" charset="0"/>
+                <a:ea typeface="BIZ UDGothic" pitchFamily="34" charset="-122"/>
+                <a:cs typeface="BIZ UDGothic" pitchFamily="34" charset="-120"/>
               </a:rPr>
               <a:t>  (ipc-write (c . entity))</a:t>
             </a:r>
@@ -7751,9 +7803,9 @@
                 <a:solidFill>
                   <a:srgbClr val="E8ECF3"/>
                 </a:solidFill>
-                <a:latin typeface="Noto Sans Mono CJK JP" pitchFamily="34" charset="0"/>
-                <a:ea typeface="Noto Sans Mono CJK JP" pitchFamily="34" charset="-122"/>
-                <a:cs typeface="Noto Sans Mono CJK JP" pitchFamily="34" charset="-120"/>
+                <a:latin typeface="BIZ UDGothic" pitchFamily="34" charset="0"/>
+                <a:ea typeface="BIZ UDGothic" pitchFamily="34" charset="-122"/>
+                <a:cs typeface="BIZ UDGothic" pitchFamily="34" charset="-120"/>
               </a:rPr>
               <a:t>  (ipc-read (c . entity)))        ; unix:uread で直接書き込む</a:t>
             </a:r>
@@ -7774,9 +7826,9 @@
                 <a:solidFill>
                   <a:srgbClr val="E8ECF3"/>
                 </a:solidFill>
-                <a:latin typeface="Noto Sans Mono CJK JP" pitchFamily="34" charset="0"/>
-                <a:ea typeface="Noto Sans Mono CJK JP" pitchFamily="34" charset="-122"/>
-                <a:cs typeface="Noto Sans Mono CJK JP" pitchFamily="34" charset="-120"/>
+                <a:latin typeface="BIZ UDGothic" pitchFamily="34" charset="0"/>
+                <a:ea typeface="BIZ UDGothic" pitchFamily="34" charset="-122"/>
+                <a:cs typeface="BIZ UDGothic" pitchFamily="34" charset="-120"/>
               </a:rPr>
               <a:t># Python 側</a:t>
             </a:r>
@@ -7791,9 +7843,9 @@
                 <a:solidFill>
                   <a:srgbClr val="E8ECF3"/>
                 </a:solidFill>
-                <a:latin typeface="Noto Sans Mono CJK JP" pitchFamily="34" charset="0"/>
-                <a:ea typeface="Noto Sans Mono CJK JP" pitchFamily="34" charset="-122"/>
-                <a:cs typeface="Noto Sans Mono CJK JP" pitchFamily="34" charset="-120"/>
+                <a:latin typeface="BIZ UDGothic" pitchFamily="34" charset="0"/>
+                <a:ea typeface="BIZ UDGothic" pitchFamily="34" charset="-122"/>
+                <a:cs typeface="BIZ UDGothic" pitchFamily="34" charset="-120"/>
               </a:rPr>
               <a:t>A = torch.from_numpy(np.frombuffer(buf)).to('cuda')</a:t>
             </a:r>
@@ -7808,9 +7860,9 @@
                 <a:solidFill>
                   <a:srgbClr val="E8ECF3"/>
                 </a:solidFill>
-                <a:latin typeface="Noto Sans Mono CJK JP" pitchFamily="34" charset="0"/>
-                <a:ea typeface="Noto Sans Mono CJK JP" pitchFamily="34" charset="-122"/>
-                <a:cs typeface="Noto Sans Mono CJK JP" pitchFamily="34" charset="-120"/>
+                <a:latin typeface="BIZ UDGothic" pitchFamily="34" charset="0"/>
+                <a:ea typeface="BIZ UDGothic" pitchFamily="34" charset="-122"/>
+                <a:cs typeface="BIZ UDGothic" pitchFamily="34" charset="-120"/>
               </a:rPr>
               <a:t>C = alpha * (A @ B) + beta * C</a:t>
             </a:r>
@@ -21476,9 +21528,9 @@
                 <a:solidFill>
                   <a:srgbClr val="E8ECF3"/>
                 </a:solidFill>
-                <a:latin typeface="Noto Sans Mono CJK JP" pitchFamily="34" charset="0"/>
-                <a:ea typeface="Noto Sans Mono CJK JP" pitchFamily="34" charset="-122"/>
-                <a:cs typeface="Noto Sans Mono CJK JP" pitchFamily="34" charset="-120"/>
+                <a:latin typeface="BIZ UDGothic" pitchFamily="34" charset="0"/>
+                <a:ea typeface="BIZ UDGothic" pitchFamily="34" charset="-122"/>
+                <a:cs typeface="BIZ UDGothic" pitchFamily="34" charset="-120"/>
               </a:rPr>
               <a:t>(setq W (make-matrix out-dim in-dim))</a:t>
             </a:r>
@@ -21493,9 +21545,9 @@
                 <a:solidFill>
                   <a:srgbClr val="E8ECF3"/>
                 </a:solidFill>
-                <a:latin typeface="Noto Sans Mono CJK JP" pitchFamily="34" charset="0"/>
-                <a:ea typeface="Noto Sans Mono CJK JP" pitchFamily="34" charset="-122"/>
-                <a:cs typeface="Noto Sans Mono CJK JP" pitchFamily="34" charset="-120"/>
+                <a:latin typeface="BIZ UDGothic" pitchFamily="34" charset="0"/>
+                <a:ea typeface="BIZ UDGothic" pitchFamily="34" charset="-122"/>
+                <a:cs typeface="BIZ UDGothic" pitchFamily="34" charset="-120"/>
               </a:rPr>
               <a:t>(setq Wt (transpose W))   ; ← W はまだ 0</a:t>
             </a:r>
@@ -21510,9 +21562,9 @@
                 <a:solidFill>
                   <a:srgbClr val="E8ECF3"/>
                 </a:solidFill>
-                <a:latin typeface="Noto Sans Mono CJK JP" pitchFamily="34" charset="0"/>
-                <a:ea typeface="Noto Sans Mono CJK JP" pitchFamily="34" charset="-122"/>
-                <a:cs typeface="Noto Sans Mono CJK JP" pitchFamily="34" charset="-120"/>
+                <a:latin typeface="BIZ UDGothic" pitchFamily="34" charset="0"/>
+                <a:ea typeface="BIZ UDGothic" pitchFamily="34" charset="-122"/>
+                <a:cs typeface="BIZ UDGothic" pitchFamily="34" charset="-120"/>
               </a:rPr>
               <a:t>(dotimes (i ...) (dotimes (j ...)</a:t>
             </a:r>
@@ -21527,9 +21579,9 @@
                 <a:solidFill>
                   <a:srgbClr val="E8ECF3"/>
                 </a:solidFill>
-                <a:latin typeface="Noto Sans Mono CJK JP" pitchFamily="34" charset="0"/>
-                <a:ea typeface="Noto Sans Mono CJK JP" pitchFamily="34" charset="-122"/>
-                <a:cs typeface="Noto Sans Mono CJK JP" pitchFamily="34" charset="-120"/>
+                <a:latin typeface="BIZ UDGothic" pitchFamily="34" charset="0"/>
+                <a:ea typeface="BIZ UDGothic" pitchFamily="34" charset="-122"/>
+                <a:cs typeface="BIZ UDGothic" pitchFamily="34" charset="-120"/>
               </a:rPr>
               <a:t>  (setf (aref W i j) (- (random 0.16) 0.08))))</a:t>
             </a:r>
@@ -23802,9 +23854,9 @@
                 <a:solidFill>
                   <a:srgbClr val="E8ECF3"/>
                 </a:solidFill>
-                <a:latin typeface="Noto Sans Mono CJK JP" pitchFamily="34" charset="0"/>
-                <a:ea typeface="Noto Sans Mono CJK JP" pitchFamily="34" charset="-122"/>
-                <a:cs typeface="Noto Sans Mono CJK JP" pitchFamily="34" charset="-120"/>
+                <a:latin typeface="BIZ UDGothic" pitchFamily="34" charset="0"/>
+                <a:ea typeface="BIZ UDGothic" pitchFamily="34" charset="-122"/>
+                <a:cs typeface="BIZ UDGothic" pitchFamily="34" charset="-120"/>
               </a:rPr>
               <a:t>CUDA/src/cudamlp.cu   GPU 計算本体 (cuBLAS + カーネル, FP64/FP32) と C+OpenBLAS 版</a:t>
             </a:r>
@@ -23819,9 +23871,9 @@
                 <a:solidFill>
                   <a:srgbClr val="E8ECF3"/>
                 </a:solidFill>
-                <a:latin typeface="Noto Sans Mono CJK JP" pitchFamily="34" charset="0"/>
-                <a:ea typeface="Noto Sans Mono CJK JP" pitchFamily="34" charset="-122"/>
-                <a:cs typeface="Noto Sans Mono CJK JP" pitchFamily="34" charset="-120"/>
+                <a:latin typeface="BIZ UDGothic" pitchFamily="34" charset="0"/>
+                <a:ea typeface="BIZ UDGothic" pitchFamily="34" charset="-122"/>
+                <a:cs typeface="BIZ UDGothic" pitchFamily="34" charset="-120"/>
               </a:rPr>
               <a:t>CUDA/Makefile         → CUDA/LinuxARM/libcudamlp.so</a:t>
             </a:r>
@@ -23836,9 +23888,9 @@
                 <a:solidFill>
                   <a:srgbClr val="E8ECF3"/>
                 </a:solidFill>
-                <a:latin typeface="Noto Sans Mono CJK JP" pitchFamily="34" charset="0"/>
-                <a:ea typeface="Noto Sans Mono CJK JP" pitchFamily="34" charset="-122"/>
-                <a:cs typeface="Noto Sans Mono CJK JP" pitchFamily="34" charset="-120"/>
+                <a:latin typeface="BIZ UDGothic" pitchFamily="34" charset="0"/>
+                <a:ea typeface="BIZ UDGothic" pitchFamily="34" charset="-122"/>
+                <a:cs typeface="BIZ UDGothic" pitchFamily="34" charset="-120"/>
               </a:rPr>
               <a:t>cudalib.l             方法 A: defforeign の定義と Lisp の関数</a:t>
             </a:r>
@@ -23853,9 +23905,9 @@
                 <a:solidFill>
                   <a:srgbClr val="E8ECF3"/>
                 </a:solidFill>
-                <a:latin typeface="Noto Sans Mono CJK JP" pitchFamily="34" charset="0"/>
-                <a:ea typeface="Noto Sans Mono CJK JP" pitchFamily="34" charset="-122"/>
-                <a:cs typeface="Noto Sans Mono CJK JP" pitchFamily="34" charset="-120"/>
+                <a:latin typeface="BIZ UDGothic" pitchFamily="34" charset="0"/>
+                <a:ea typeface="BIZ UDGothic" pitchFamily="34" charset="-122"/>
+                <a:cs typeface="BIZ UDGothic" pitchFamily="34" charset="-120"/>
               </a:rPr>
               <a:t>CUDAPROD/src/cudaprod.c, Makefile   方法 B: MATPROD 形式のモジュール</a:t>
             </a:r>
@@ -23870,9 +23922,9 @@
                 <a:solidFill>
                   <a:srgbClr val="E8ECF3"/>
                 </a:solidFill>
-                <a:latin typeface="Noto Sans Mono CJK JP" pitchFamily="34" charset="0"/>
-                <a:ea typeface="Noto Sans Mono CJK JP" pitchFamily="34" charset="-122"/>
-                <a:cs typeface="Noto Sans Mono CJK JP" pitchFamily="34" charset="-120"/>
+                <a:latin typeface="BIZ UDGothic" pitchFamily="34" charset="0"/>
+                <a:ea typeface="BIZ UDGothic" pitchFamily="34" charset="-122"/>
+                <a:cs typeface="BIZ UDGothic" pitchFamily="34" charset="-120"/>
               </a:rPr>
               <a:t>cuda-direct.l         方法 C: libcublas.so を直接 defforeign</a:t>
             </a:r>
@@ -23887,9 +23939,9 @@
                 <a:solidFill>
                   <a:srgbClr val="E8ECF3"/>
                 </a:solidFill>
-                <a:latin typeface="Noto Sans Mono CJK JP" pitchFamily="34" charset="0"/>
-                <a:ea typeface="Noto Sans Mono CJK JP" pitchFamily="34" charset="-122"/>
-                <a:cs typeface="Noto Sans Mono CJK JP" pitchFamily="34" charset="-120"/>
+                <a:latin typeface="BIZ UDGothic" pitchFamily="34" charset="0"/>
+                <a:ea typeface="BIZ UDGothic" pitchFamily="34" charset="-122"/>
+                <a:cs typeface="BIZ UDGothic" pitchFamily="34" charset="-120"/>
               </a:rPr>
               <a:t>cuda-ipc.l, ipc/torch_server.py     方法 D: PyTorch 別プロセス</a:t>
             </a:r>
@@ -23904,9 +23956,9 @@
                 <a:solidFill>
                   <a:srgbClr val="E8ECF3"/>
                 </a:solidFill>
-                <a:latin typeface="Noto Sans Mono CJK JP" pitchFamily="34" charset="0"/>
-                <a:ea typeface="Noto Sans Mono CJK JP" pitchFamily="34" charset="-122"/>
-                <a:cs typeface="Noto Sans Mono CJK JP" pitchFamily="34" charset="-120"/>
+                <a:latin typeface="BIZ UDGothic" pitchFamily="34" charset="0"/>
+                <a:ea typeface="BIZ UDGothic" pitchFamily="34" charset="-122"/>
+                <a:cs typeface="BIZ UDGothic" pitchFamily="34" charset="-120"/>
               </a:rPr>
               <a:t>nn-cuda.l             学習・テストの関数 (nn.l を読み込む)</a:t>
             </a:r>
@@ -23921,9 +23973,9 @@
                 <a:solidFill>
                   <a:srgbClr val="E8ECF3"/>
                 </a:solidFill>
-                <a:latin typeface="Noto Sans Mono CJK JP" pitchFamily="34" charset="0"/>
-                <a:ea typeface="Noto Sans Mono CJK JP" pitchFamily="34" charset="-122"/>
-                <a:cs typeface="Noto Sans Mono CJK JP" pitchFamily="34" charset="-120"/>
+                <a:latin typeface="BIZ UDGothic" pitchFamily="34" charset="0"/>
+                <a:ea typeface="BIZ UDGothic" pitchFamily="34" charset="-122"/>
+                <a:cs typeface="BIZ UDGothic" pitchFamily="34" charset="-120"/>
               </a:rPr>
               <a:t>bench-cuda.l          本スライドの計測 (RESULT 行を出力)</a:t>
             </a:r>
@@ -23964,9 +24016,9 @@
                 <a:solidFill>
                   <a:srgbClr val="E8ECF3"/>
                 </a:solidFill>
-                <a:latin typeface="Noto Sans Mono CJK JP" pitchFamily="34" charset="0"/>
-                <a:ea typeface="Noto Sans Mono CJK JP" pitchFamily="34" charset="-122"/>
-                <a:cs typeface="Noto Sans Mono CJK JP" pitchFamily="34" charset="-120"/>
+                <a:latin typeface="BIZ UDGothic" pitchFamily="34" charset="0"/>
+                <a:ea typeface="BIZ UDGothic" pitchFamily="34" charset="-122"/>
+                <a:cs typeface="BIZ UDGothic" pitchFamily="34" charset="-120"/>
               </a:rPr>
               <a:t>$ (cd CUDA; make) &amp;&amp; (cd CUDAPROD; make)</a:t>
             </a:r>
@@ -23981,9 +24033,9 @@
                 <a:solidFill>
                   <a:srgbClr val="E8ECF3"/>
                 </a:solidFill>
-                <a:latin typeface="Noto Sans Mono CJK JP" pitchFamily="34" charset="0"/>
-                <a:ea typeface="Noto Sans Mono CJK JP" pitchFamily="34" charset="-122"/>
-                <a:cs typeface="Noto Sans Mono CJK JP" pitchFamily="34" charset="-120"/>
+                <a:latin typeface="BIZ UDGothic" pitchFamily="34" charset="0"/>
+                <a:ea typeface="BIZ UDGothic" pitchFamily="34" charset="-122"/>
+                <a:cs typeface="BIZ UDGothic" pitchFamily="34" charset="-120"/>
               </a:rPr>
               <a:t>$ roseus nn-cuda.l</a:t>
             </a:r>
@@ -23998,9 +24050,9 @@
                 <a:solidFill>
                   <a:srgbClr val="E8ECF3"/>
                 </a:solidFill>
-                <a:latin typeface="Noto Sans Mono CJK JP" pitchFamily="34" charset="0"/>
-                <a:ea typeface="Noto Sans Mono CJK JP" pitchFamily="34" charset="-122"/>
-                <a:cs typeface="Noto Sans Mono CJK JP" pitchFamily="34" charset="-120"/>
+                <a:latin typeface="BIZ UDGothic" pitchFamily="34" charset="0"/>
+                <a:ea typeface="BIZ UDGothic" pitchFamily="34" charset="-122"/>
+                <a:cs typeface="BIZ UDGothic" pitchFamily="34" charset="-120"/>
               </a:rPr>
               <a:t>$ (test-mnist-batch-cuda 200)                 ;; GPU 常駐 FP64 で 20 エポック</a:t>
             </a:r>
@@ -24015,9 +24067,9 @@
                 <a:solidFill>
                   <a:srgbClr val="E8ECF3"/>
                 </a:solidFill>
-                <a:latin typeface="Noto Sans Mono CJK JP" pitchFamily="34" charset="0"/>
-                <a:ea typeface="Noto Sans Mono CJK JP" pitchFamily="34" charset="-122"/>
-                <a:cs typeface="Noto Sans Mono CJK JP" pitchFamily="34" charset="-120"/>
+                <a:latin typeface="BIZ UDGothic" pitchFamily="34" charset="0"/>
+                <a:ea typeface="BIZ UDGothic" pitchFamily="34" charset="-122"/>
+                <a:cs typeface="BIZ UDGothic" pitchFamily="34" charset="-120"/>
               </a:rPr>
               <a:t>$ (test-mnist-batch-cuda 200 :precision 32)   ;; FP32</a:t>
             </a:r>
@@ -24032,9 +24084,9 @@
                 <a:solidFill>
                   <a:srgbClr val="E8ECF3"/>
                 </a:solidFill>
-                <a:latin typeface="Noto Sans Mono CJK JP" pitchFamily="34" charset="0"/>
-                <a:ea typeface="Noto Sans Mono CJK JP" pitchFamily="34" charset="-122"/>
-                <a:cs typeface="Noto Sans Mono CJK JP" pitchFamily="34" charset="-120"/>
+                <a:latin typeface="BIZ UDGothic" pitchFamily="34" charset="0"/>
+                <a:ea typeface="BIZ UDGothic" pitchFamily="34" charset="-122"/>
+                <a:cs typeface="BIZ UDGothic" pitchFamily="34" charset="-120"/>
               </a:rPr>
               <a:t>$ (test-mnist-batch-lisp 200 :dgemm :cuda)    ;; nn.l のループのまま dgemm だけ GPU</a:t>
             </a:r>
@@ -24049,9 +24101,9 @@
                 <a:solidFill>
                   <a:srgbClr val="E8ECF3"/>
                 </a:solidFill>
-                <a:latin typeface="Noto Sans Mono CJK JP" pitchFamily="34" charset="0"/>
-                <a:ea typeface="Noto Sans Mono CJK JP" pitchFamily="34" charset="-122"/>
-                <a:cs typeface="Noto Sans Mono CJK JP" pitchFamily="34" charset="-120"/>
+                <a:latin typeface="BIZ UDGothic" pitchFamily="34" charset="0"/>
+                <a:ea typeface="BIZ UDGothic" pitchFamily="34" charset="-122"/>
+                <a:cs typeface="BIZ UDGothic" pitchFamily="34" charset="-120"/>
               </a:rPr>
               <a:t>$ (test-mnist-cuda-test)                      ;; mlp/mnist-mlp-19.l を GPU で認識</a:t>
             </a:r>
@@ -24066,9 +24118,9 @@
                 <a:solidFill>
                   <a:srgbClr val="E8ECF3"/>
                 </a:solidFill>
-                <a:latin typeface="Noto Sans Mono CJK JP" pitchFamily="34" charset="0"/>
-                <a:ea typeface="Noto Sans Mono CJK JP" pitchFamily="34" charset="-122"/>
-                <a:cs typeface="Noto Sans Mono CJK JP" pitchFamily="34" charset="-120"/>
+                <a:latin typeface="BIZ UDGothic" pitchFamily="34" charset="0"/>
+                <a:ea typeface="BIZ UDGothic" pitchFamily="34" charset="-122"/>
+                <a:cs typeface="BIZ UDGothic" pitchFamily="34" charset="-120"/>
               </a:rPr>
               <a:t>$ irteusgl bench-cuda.l                       ;; 接続方法の比較 (約 10 分)</a:t>
             </a:r>
@@ -26619,9 +26671,9 @@
                 <a:solidFill>
                   <a:schemeClr val="accent2"/>
                 </a:solidFill>
-                <a:latin typeface="Noto Sans Mono CJK JP" pitchFamily="34" charset="0"/>
-                <a:ea typeface="Noto Sans Mono CJK JP" pitchFamily="34" charset="-122"/>
-                <a:cs typeface="Noto Sans Mono CJK JP" pitchFamily="34" charset="-120"/>
+                <a:latin typeface="BIZ UDGothic" pitchFamily="34" charset="0"/>
+                <a:ea typeface="BIZ UDGothic" pitchFamily="34" charset="-122"/>
+                <a:cs typeface="BIZ UDGothic" pitchFamily="34" charset="-120"/>
               </a:rPr>
               <a:t>cudalib.l → CUDA/&lt;arch&gt;/libcudamlp.so</a:t>
             </a:r>
@@ -26723,9 +26775,9 @@
                 <a:solidFill>
                   <a:schemeClr val="accent2"/>
                 </a:solidFill>
-                <a:latin typeface="Noto Sans Mono CJK JP" pitchFamily="34" charset="0"/>
-                <a:ea typeface="Noto Sans Mono CJK JP" pitchFamily="34" charset="-122"/>
-                <a:cs typeface="Noto Sans Mono CJK JP" pitchFamily="34" charset="-120"/>
+                <a:latin typeface="BIZ UDGothic" pitchFamily="34" charset="0"/>
+                <a:ea typeface="BIZ UDGothic" pitchFamily="34" charset="-122"/>
+                <a:cs typeface="BIZ UDGothic" pitchFamily="34" charset="-120"/>
               </a:rPr>
               <a:t>CUDAPROD/&lt;arch&gt;/libcudaprod.so</a:t>
             </a:r>
@@ -26827,9 +26879,9 @@
                 <a:solidFill>
                   <a:schemeClr val="accent2"/>
                 </a:solidFill>
-                <a:latin typeface="Noto Sans Mono CJK JP" pitchFamily="34" charset="0"/>
-                <a:ea typeface="Noto Sans Mono CJK JP" pitchFamily="34" charset="-122"/>
-                <a:cs typeface="Noto Sans Mono CJK JP" pitchFamily="34" charset="-120"/>
+                <a:latin typeface="BIZ UDGothic" pitchFamily="34" charset="0"/>
+                <a:ea typeface="BIZ UDGothic" pitchFamily="34" charset="-122"/>
+                <a:cs typeface="BIZ UDGothic" pitchFamily="34" charset="-120"/>
               </a:rPr>
               <a:t>cuda-direct.l</a:t>
             </a:r>
@@ -26931,9 +26983,9 @@
                 <a:solidFill>
                   <a:schemeClr val="accent2"/>
                 </a:solidFill>
-                <a:latin typeface="Noto Sans Mono CJK JP" pitchFamily="34" charset="0"/>
-                <a:ea typeface="Noto Sans Mono CJK JP" pitchFamily="34" charset="-122"/>
-                <a:cs typeface="Noto Sans Mono CJK JP" pitchFamily="34" charset="-120"/>
+                <a:latin typeface="BIZ UDGothic" pitchFamily="34" charset="0"/>
+                <a:ea typeface="BIZ UDGothic" pitchFamily="34" charset="-122"/>
+                <a:cs typeface="BIZ UDGothic" pitchFamily="34" charset="-120"/>
               </a:rPr>
               <a:t>cuda-ipc.l + ipc/torch_server.py</a:t>
             </a:r>
@@ -27165,9 +27217,9 @@
                 <a:solidFill>
                   <a:srgbClr val="E8ECF3"/>
                 </a:solidFill>
-                <a:latin typeface="Noto Sans Mono CJK JP" pitchFamily="34" charset="0"/>
-                <a:ea typeface="Noto Sans Mono CJK JP" pitchFamily="34" charset="-122"/>
-                <a:cs typeface="Noto Sans Mono CJK JP" pitchFamily="34" charset="-120"/>
+                <a:latin typeface="BIZ UDGothic" pitchFamily="34" charset="0"/>
+                <a:ea typeface="BIZ UDGothic" pitchFamily="34" charset="-122"/>
+                <a:cs typeface="BIZ UDGothic" pitchFamily="34" charset="-120"/>
               </a:rPr>
               <a:t>;; cudalib.l</a:t>
             </a:r>
@@ -27182,9 +27234,9 @@
                 <a:solidFill>
                   <a:srgbClr val="E8ECF3"/>
                 </a:solidFill>
-                <a:latin typeface="Noto Sans Mono CJK JP" pitchFamily="34" charset="0"/>
-                <a:ea typeface="Noto Sans Mono CJK JP" pitchFamily="34" charset="-122"/>
-                <a:cs typeface="Noto Sans Mono CJK JP" pitchFamily="34" charset="-120"/>
+                <a:latin typeface="BIZ UDGothic" pitchFamily="34" charset="0"/>
+                <a:ea typeface="BIZ UDGothic" pitchFamily="34" charset="-122"/>
+                <a:cs typeface="BIZ UDGothic" pitchFamily="34" charset="-120"/>
               </a:rPr>
               <a:t>(setq *cudamlplib* (load-foreign "CUDA/LinuxARM/libcudamlp.so"))</a:t>
             </a:r>
@@ -27199,9 +27251,9 @@
                 <a:solidFill>
                   <a:srgbClr val="E8ECF3"/>
                 </a:solidFill>
-                <a:latin typeface="Noto Sans Mono CJK JP" pitchFamily="34" charset="0"/>
-                <a:ea typeface="Noto Sans Mono CJK JP" pitchFamily="34" charset="-122"/>
-                <a:cs typeface="Noto Sans Mono CJK JP" pitchFamily="34" charset="-120"/>
+                <a:latin typeface="BIZ UDGothic" pitchFamily="34" charset="0"/>
+                <a:ea typeface="BIZ UDGothic" pitchFamily="34" charset="-122"/>
+                <a:cs typeface="BIZ UDGothic" pitchFamily="34" charset="-120"/>
               </a:rPr>
               <a:t>(defforeign cuda_dgemm_host *cudamlplib* "cuda_dgemm_host" () :integer)</a:t>
             </a:r>
@@ -27216,9 +27268,9 @@
                 <a:solidFill>
                   <a:srgbClr val="E8ECF3"/>
                 </a:solidFill>
-                <a:latin typeface="Noto Sans Mono CJK JP" pitchFamily="34" charset="0"/>
-                <a:ea typeface="Noto Sans Mono CJK JP" pitchFamily="34" charset="-122"/>
-                <a:cs typeface="Noto Sans Mono CJK JP" pitchFamily="34" charset="-120"/>
+                <a:latin typeface="BIZ UDGothic" pitchFamily="34" charset="0"/>
+                <a:ea typeface="BIZ UDGothic" pitchFamily="34" charset="-122"/>
+                <a:cs typeface="BIZ UDGothic" pitchFamily="34" charset="-120"/>
               </a:rPr>
               <a:t>(defforeign cmlp_train_epoch *cudamlplib* "cmlp_train_epoch" () :float)</a:t>
             </a:r>
@@ -27239,9 +27291,9 @@
                 <a:solidFill>
                   <a:srgbClr val="E8ECF3"/>
                 </a:solidFill>
-                <a:latin typeface="Noto Sans Mono CJK JP" pitchFamily="34" charset="0"/>
-                <a:ea typeface="Noto Sans Mono CJK JP" pitchFamily="34" charset="-122"/>
-                <a:cs typeface="Noto Sans Mono CJK JP" pitchFamily="34" charset="-120"/>
+                <a:latin typeface="BIZ UDGothic" pitchFamily="34" charset="0"/>
+                <a:ea typeface="BIZ UDGothic" pitchFamily="34" charset="-122"/>
+                <a:cs typeface="BIZ UDGothic" pitchFamily="34" charset="-120"/>
               </a:rPr>
               <a:t>(defun cuda-dgemm (a b c &amp;optional (alpha 1.0) (beta 1.0))</a:t>
             </a:r>
@@ -27256,9 +27308,9 @@
                 <a:solidFill>
                   <a:srgbClr val="E8ECF3"/>
                 </a:solidFill>
-                <a:latin typeface="Noto Sans Mono CJK JP" pitchFamily="34" charset="0"/>
-                <a:ea typeface="Noto Sans Mono CJK JP" pitchFamily="34" charset="-122"/>
-                <a:cs typeface="Noto Sans Mono CJK JP" pitchFamily="34" charset="-120"/>
+                <a:latin typeface="BIZ UDGothic" pitchFamily="34" charset="0"/>
+                <a:ea typeface="BIZ UDGothic" pitchFamily="34" charset="-122"/>
+                <a:cs typeface="BIZ UDGothic" pitchFamily="34" charset="-120"/>
               </a:rPr>
               <a:t>  (cuda_dgemm_host (array-dimension a 0) (array-dimension b 1)</a:t>
             </a:r>
@@ -27273,9 +27325,9 @@
                 <a:solidFill>
                   <a:srgbClr val="E8ECF3"/>
                 </a:solidFill>
-                <a:latin typeface="Noto Sans Mono CJK JP" pitchFamily="34" charset="0"/>
-                <a:ea typeface="Noto Sans Mono CJK JP" pitchFamily="34" charset="-122"/>
-                <a:cs typeface="Noto Sans Mono CJK JP" pitchFamily="34" charset="-120"/>
+                <a:latin typeface="BIZ UDGothic" pitchFamily="34" charset="0"/>
+                <a:ea typeface="BIZ UDGothic" pitchFamily="34" charset="-122"/>
+                <a:cs typeface="BIZ UDGothic" pitchFamily="34" charset="-120"/>
               </a:rPr>
               <a:t>                   (array-dimension a 1) alpha</a:t>
             </a:r>
@@ -27290,9 +27342,9 @@
                 <a:solidFill>
                   <a:srgbClr val="E8ECF3"/>
                 </a:solidFill>
-                <a:latin typeface="Noto Sans Mono CJK JP" pitchFamily="34" charset="0"/>
-                <a:ea typeface="Noto Sans Mono CJK JP" pitchFamily="34" charset="-122"/>
-                <a:cs typeface="Noto Sans Mono CJK JP" pitchFamily="34" charset="-120"/>
+                <a:latin typeface="BIZ UDGothic" pitchFamily="34" charset="0"/>
+                <a:ea typeface="BIZ UDGothic" pitchFamily="34" charset="-122"/>
+                <a:cs typeface="BIZ UDGothic" pitchFamily="34" charset="-120"/>
               </a:rPr>
               <a:t>                   (a . entity) (b . entity) beta (c . entity))</a:t>
             </a:r>
@@ -27307,9 +27359,9 @@
                 <a:solidFill>
                   <a:srgbClr val="E8ECF3"/>
                 </a:solidFill>
-                <a:latin typeface="Noto Sans Mono CJK JP" pitchFamily="34" charset="0"/>
-                <a:ea typeface="Noto Sans Mono CJK JP" pitchFamily="34" charset="-122"/>
-                <a:cs typeface="Noto Sans Mono CJK JP" pitchFamily="34" charset="-120"/>
+                <a:latin typeface="BIZ UDGothic" pitchFamily="34" charset="0"/>
+                <a:ea typeface="BIZ UDGothic" pitchFamily="34" charset="-122"/>
+                <a:cs typeface="BIZ UDGothic" pitchFamily="34" charset="-120"/>
               </a:rPr>
               <a:t>  c)</a:t>
             </a:r>
@@ -27330,9 +27382,9 @@
                 <a:solidFill>
                   <a:srgbClr val="E8ECF3"/>
                 </a:solidFill>
-                <a:latin typeface="Noto Sans Mono CJK JP" pitchFamily="34" charset="0"/>
-                <a:ea typeface="Noto Sans Mono CJK JP" pitchFamily="34" charset="-122"/>
-                <a:cs typeface="Noto Sans Mono CJK JP" pitchFamily="34" charset="-120"/>
+                <a:latin typeface="BIZ UDGothic" pitchFamily="34" charset="0"/>
+                <a:ea typeface="BIZ UDGothic" pitchFamily="34" charset="-122"/>
+                <a:cs typeface="BIZ UDGothic" pitchFamily="34" charset="-120"/>
               </a:rPr>
               <a:t>// CUDA/src/cudamlp.cu</a:t>
             </a:r>
@@ -27347,9 +27399,9 @@
                 <a:solidFill>
                   <a:srgbClr val="E8ECF3"/>
                 </a:solidFill>
-                <a:latin typeface="Noto Sans Mono CJK JP" pitchFamily="34" charset="0"/>
-                <a:ea typeface="Noto Sans Mono CJK JP" pitchFamily="34" charset="-122"/>
-                <a:cs typeface="Noto Sans Mono CJK JP" pitchFamily="34" charset="-120"/>
+                <a:latin typeface="BIZ UDGothic" pitchFamily="34" charset="0"/>
+                <a:ea typeface="BIZ UDGothic" pitchFamily="34" charset="-122"/>
+                <a:cs typeface="BIZ UDGothic" pitchFamily="34" charset="-120"/>
               </a:rPr>
               <a:t>extern "C" long cuda_dgemm_host(long m, long n, long k,</a:t>
             </a:r>
@@ -27364,9 +27416,9 @@
                 <a:solidFill>
                   <a:srgbClr val="E8ECF3"/>
                 </a:solidFill>
-                <a:latin typeface="Noto Sans Mono CJK JP" pitchFamily="34" charset="0"/>
-                <a:ea typeface="Noto Sans Mono CJK JP" pitchFamily="34" charset="-122"/>
-                <a:cs typeface="Noto Sans Mono CJK JP" pitchFamily="34" charset="-120"/>
+                <a:latin typeface="BIZ UDGothic" pitchFamily="34" charset="0"/>
+                <a:ea typeface="BIZ UDGothic" pitchFamily="34" charset="-122"/>
+                <a:cs typeface="BIZ UDGothic" pitchFamily="34" charset="-120"/>
               </a:rPr>
               <a:t>    double alpha, const double *A, const double *B,</a:t>
             </a:r>
@@ -27381,9 +27433,9 @@
                 <a:solidFill>
                   <a:srgbClr val="E8ECF3"/>
                 </a:solidFill>
-                <a:latin typeface="Noto Sans Mono CJK JP" pitchFamily="34" charset="0"/>
-                <a:ea typeface="Noto Sans Mono CJK JP" pitchFamily="34" charset="-122"/>
-                <a:cs typeface="Noto Sans Mono CJK JP" pitchFamily="34" charset="-120"/>
+                <a:latin typeface="BIZ UDGothic" pitchFamily="34" charset="0"/>
+                <a:ea typeface="BIZ UDGothic" pitchFamily="34" charset="-122"/>
+                <a:cs typeface="BIZ UDGothic" pitchFamily="34" charset="-120"/>
               </a:rPr>
               <a:t>    double beta, double *C) { ... cublasDgemm ... }</a:t>
             </a:r>
@@ -27818,9 +27870,9 @@
                 <a:solidFill>
                   <a:srgbClr val="E8ECF3"/>
                 </a:solidFill>
-                <a:latin typeface="Noto Sans Mono CJK JP" pitchFamily="34" charset="0"/>
-                <a:ea typeface="Noto Sans Mono CJK JP" pitchFamily="34" charset="-122"/>
-                <a:cs typeface="Noto Sans Mono CJK JP" pitchFamily="34" charset="-120"/>
+                <a:latin typeface="BIZ UDGothic" pitchFamily="34" charset="0"/>
+                <a:ea typeface="BIZ UDGothic" pitchFamily="34" charset="-122"/>
+                <a:cs typeface="BIZ UDGothic" pitchFamily="34" charset="-120"/>
               </a:rPr>
               <a:t>/* CUDAPROD/src/cudaprod.c */</a:t>
             </a:r>
@@ -27835,9 +27887,9 @@
                 <a:solidFill>
                   <a:srgbClr val="E8ECF3"/>
                 </a:solidFill>
-                <a:latin typeface="Noto Sans Mono CJK JP" pitchFamily="34" charset="0"/>
-                <a:ea typeface="Noto Sans Mono CJK JP" pitchFamily="34" charset="-122"/>
-                <a:cs typeface="Noto Sans Mono CJK JP" pitchFamily="34" charset="-120"/>
+                <a:latin typeface="BIZ UDGothic" pitchFamily="34" charset="0"/>
+                <a:ea typeface="BIZ UDGothic" pitchFamily="34" charset="-122"/>
+                <a:cs typeface="BIZ UDGothic" pitchFamily="34" charset="-120"/>
               </a:rPr>
               <a:t>#include &lt;eus.h&gt;</a:t>
             </a:r>
@@ -27852,9 +27904,9 @@
                 <a:solidFill>
                   <a:srgbClr val="E8ECF3"/>
                 </a:solidFill>
-                <a:latin typeface="Noto Sans Mono CJK JP" pitchFamily="34" charset="0"/>
-                <a:ea typeface="Noto Sans Mono CJK JP" pitchFamily="34" charset="-122"/>
-                <a:cs typeface="Noto Sans Mono CJK JP" pitchFamily="34" charset="-120"/>
+                <a:latin typeface="BIZ UDGothic" pitchFamily="34" charset="0"/>
+                <a:ea typeface="BIZ UDGothic" pitchFamily="34" charset="-122"/>
+                <a:cs typeface="BIZ UDGothic" pitchFamily="34" charset="-120"/>
               </a:rPr>
               <a:t>pointer CUDADGEMM(register context *ctx, int n, pointer *argv)</a:t>
             </a:r>
@@ -27869,9 +27921,9 @@
                 <a:solidFill>
                   <a:srgbClr val="E8ECF3"/>
                 </a:solidFill>
-                <a:latin typeface="Noto Sans Mono CJK JP" pitchFamily="34" charset="0"/>
-                <a:ea typeface="Noto Sans Mono CJK JP" pitchFamily="34" charset="-122"/>
-                <a:cs typeface="Noto Sans Mono CJK JP" pitchFamily="34" charset="-120"/>
+                <a:latin typeface="BIZ UDGothic" pitchFamily="34" charset="0"/>
+                <a:ea typeface="BIZ UDGothic" pitchFamily="34" charset="-122"/>
+                <a:cs typeface="BIZ UDGothic" pitchFamily="34" charset="-120"/>
               </a:rPr>
               <a:t>{ pointer a = argv[0], b = argv[1], c = argv[2];</a:t>
             </a:r>
@@ -27886,9 +27938,9 @@
                 <a:solidFill>
                   <a:srgbClr val="E8ECF3"/>
                 </a:solidFill>
-                <a:latin typeface="Noto Sans Mono CJK JP" pitchFamily="34" charset="0"/>
-                <a:ea typeface="Noto Sans Mono CJK JP" pitchFamily="34" charset="-122"/>
-                <a:cs typeface="Noto Sans Mono CJK JP" pitchFamily="34" charset="-120"/>
+                <a:latin typeface="BIZ UDGothic" pitchFamily="34" charset="0"/>
+                <a:ea typeface="BIZ UDGothic" pitchFamily="34" charset="-122"/>
+                <a:cs typeface="BIZ UDGothic" pitchFamily="34" charset="-120"/>
               </a:rPr>
               <a:t>  ckarg2(3, 5);</a:t>
             </a:r>
@@ -27903,9 +27955,9 @@
                 <a:solidFill>
                   <a:srgbClr val="E8ECF3"/>
                 </a:solidFill>
-                <a:latin typeface="Noto Sans Mono CJK JP" pitchFamily="34" charset="0"/>
-                <a:ea typeface="Noto Sans Mono CJK JP" pitchFamily="34" charset="-122"/>
-                <a:cs typeface="Noto Sans Mono CJK JP" pitchFamily="34" charset="-120"/>
+                <a:latin typeface="BIZ UDGothic" pitchFamily="34" charset="0"/>
+                <a:ea typeface="BIZ UDGothic" pitchFamily="34" charset="-122"/>
+                <a:cs typeface="BIZ UDGothic" pitchFamily="34" charset="-120"/>
               </a:rPr>
               <a:t>  if (!ismatrix(a) || !ismatrix(b) || !ismatrix(c)) error(E_NOVECTOR);</a:t>
             </a:r>
@@ -27920,9 +27972,9 @@
                 <a:solidFill>
                   <a:srgbClr val="E8ECF3"/>
                 </a:solidFill>
-                <a:latin typeface="Noto Sans Mono CJK JP" pitchFamily="34" charset="0"/>
-                <a:ea typeface="Noto Sans Mono CJK JP" pitchFamily="34" charset="-122"/>
-                <a:cs typeface="Noto Sans Mono CJK JP" pitchFamily="34" charset="-120"/>
+                <a:latin typeface="BIZ UDGothic" pitchFamily="34" charset="0"/>
+                <a:ea typeface="BIZ UDGothic" pitchFamily="34" charset="-122"/>
+                <a:cs typeface="BIZ UDGothic" pitchFamily="34" charset="-120"/>
               </a:rPr>
               <a:t>  if (colsize(a) != rowsize(b) || ...) error(E_VECINDEX);</a:t>
             </a:r>
@@ -27937,9 +27989,9 @@
                 <a:solidFill>
                   <a:srgbClr val="E8ECF3"/>
                 </a:solidFill>
-                <a:latin typeface="Noto Sans Mono CJK JP" pitchFamily="34" charset="0"/>
-                <a:ea typeface="Noto Sans Mono CJK JP" pitchFamily="34" charset="-122"/>
-                <a:cs typeface="Noto Sans Mono CJK JP" pitchFamily="34" charset="-120"/>
+                <a:latin typeface="BIZ UDGothic" pitchFamily="34" charset="0"/>
+                <a:ea typeface="BIZ UDGothic" pitchFamily="34" charset="-122"/>
+                <a:cs typeface="BIZ UDGothic" pitchFamily="34" charset="-120"/>
               </a:rPr>
               <a:t>  cuda_dgemm_host(rowsize(a), colsize(b), colsize(a), alpha,</a:t>
             </a:r>
@@ -27954,9 +28006,9 @@
                 <a:solidFill>
                   <a:srgbClr val="E8ECF3"/>
                 </a:solidFill>
-                <a:latin typeface="Noto Sans Mono CJK JP" pitchFamily="34" charset="0"/>
-                <a:ea typeface="Noto Sans Mono CJK JP" pitchFamily="34" charset="-122"/>
-                <a:cs typeface="Noto Sans Mono CJK JP" pitchFamily="34" charset="-120"/>
+                <a:latin typeface="BIZ UDGothic" pitchFamily="34" charset="0"/>
+                <a:ea typeface="BIZ UDGothic" pitchFamily="34" charset="-122"/>
+                <a:cs typeface="BIZ UDGothic" pitchFamily="34" charset="-120"/>
               </a:rPr>
               <a:t>                  matfv(a), matfv(b), beta, matfv(c));</a:t>
             </a:r>
@@ -27971,9 +28023,9 @@
                 <a:solidFill>
                   <a:srgbClr val="E8ECF3"/>
                 </a:solidFill>
-                <a:latin typeface="Noto Sans Mono CJK JP" pitchFamily="34" charset="0"/>
-                <a:ea typeface="Noto Sans Mono CJK JP" pitchFamily="34" charset="-122"/>
-                <a:cs typeface="Noto Sans Mono CJK JP" pitchFamily="34" charset="-120"/>
+                <a:latin typeface="BIZ UDGothic" pitchFamily="34" charset="0"/>
+                <a:ea typeface="BIZ UDGothic" pitchFamily="34" charset="-122"/>
+                <a:cs typeface="BIZ UDGothic" pitchFamily="34" charset="-120"/>
               </a:rPr>
               <a:t>  return c; }</a:t>
             </a:r>
@@ -27988,9 +28040,9 @@
                 <a:solidFill>
                   <a:srgbClr val="E8ECF3"/>
                 </a:solidFill>
-                <a:latin typeface="Noto Sans Mono CJK JP" pitchFamily="34" charset="0"/>
-                <a:ea typeface="Noto Sans Mono CJK JP" pitchFamily="34" charset="-122"/>
-                <a:cs typeface="Noto Sans Mono CJK JP" pitchFamily="34" charset="-120"/>
+                <a:latin typeface="BIZ UDGothic" pitchFamily="34" charset="0"/>
+                <a:ea typeface="BIZ UDGothic" pitchFamily="34" charset="-122"/>
+                <a:cs typeface="BIZ UDGothic" pitchFamily="34" charset="-120"/>
               </a:rPr>
               <a:t>pointer ___cudaprod(context *ctx, int n, pointer *argv)</a:t>
             </a:r>
@@ -28005,9 +28057,9 @@
                 <a:solidFill>
                   <a:srgbClr val="E8ECF3"/>
                 </a:solidFill>
-                <a:latin typeface="Noto Sans Mono CJK JP" pitchFamily="34" charset="0"/>
-                <a:ea typeface="Noto Sans Mono CJK JP" pitchFamily="34" charset="-122"/>
-                <a:cs typeface="Noto Sans Mono CJK JP" pitchFamily="34" charset="-120"/>
+                <a:latin typeface="BIZ UDGothic" pitchFamily="34" charset="0"/>
+                <a:ea typeface="BIZ UDGothic" pitchFamily="34" charset="-122"/>
+                <a:cs typeface="BIZ UDGothic" pitchFamily="34" charset="-120"/>
               </a:rPr>
               <a:t>{ defun(ctx, "CUDAPROD-DGEMM", argv[0], CUDADGEMM, NULL); ... }</a:t>
             </a:r>
@@ -28028,9 +28080,9 @@
                 <a:solidFill>
                   <a:srgbClr val="E8ECF3"/>
                 </a:solidFill>
-                <a:latin typeface="Noto Sans Mono CJK JP" pitchFamily="34" charset="0"/>
-                <a:ea typeface="Noto Sans Mono CJK JP" pitchFamily="34" charset="-122"/>
-                <a:cs typeface="Noto Sans Mono CJK JP" pitchFamily="34" charset="-120"/>
+                <a:latin typeface="BIZ UDGothic" pitchFamily="34" charset="0"/>
+                <a:ea typeface="BIZ UDGothic" pitchFamily="34" charset="-122"/>
+                <a:cs typeface="BIZ UDGothic" pitchFamily="34" charset="-120"/>
               </a:rPr>
               <a:t>;; Lisp</a:t>
             </a:r>
@@ -28045,9 +28097,9 @@
                 <a:solidFill>
                   <a:srgbClr val="E8ECF3"/>
                 </a:solidFill>
-                <a:latin typeface="Noto Sans Mono CJK JP" pitchFamily="34" charset="0"/>
-                <a:ea typeface="Noto Sans Mono CJK JP" pitchFamily="34" charset="-122"/>
-                <a:cs typeface="Noto Sans Mono CJK JP" pitchFamily="34" charset="-120"/>
+                <a:latin typeface="BIZ UDGothic" pitchFamily="34" charset="0"/>
+                <a:ea typeface="BIZ UDGothic" pitchFamily="34" charset="-122"/>
+                <a:cs typeface="BIZ UDGothic" pitchFamily="34" charset="-120"/>
               </a:rPr>
               <a:t>(load-library "CUDAPROD/LinuxARM/libcudaprod" '("cudaprod"))</a:t>
             </a:r>
@@ -28062,9 +28114,9 @@
                 <a:solidFill>
                   <a:srgbClr val="E8ECF3"/>
                 </a:solidFill>
-                <a:latin typeface="Noto Sans Mono CJK JP" pitchFamily="34" charset="0"/>
-                <a:ea typeface="Noto Sans Mono CJK JP" pitchFamily="34" charset="-122"/>
-                <a:cs typeface="Noto Sans Mono CJK JP" pitchFamily="34" charset="-120"/>
+                <a:latin typeface="BIZ UDGothic" pitchFamily="34" charset="0"/>
+                <a:ea typeface="BIZ UDGothic" pitchFamily="34" charset="-122"/>
+                <a:cs typeface="BIZ UDGothic" pitchFamily="34" charset="-120"/>
               </a:rPr>
               <a:t>(cudaprod-dgemm a b c)</a:t>
             </a:r>
@@ -28454,8 +28506,8 @@
     </a:clrScheme>
     <a:fontScheme name="MNIST Ink">
       <a:majorFont>
-        <a:latin typeface="Noto Sans CJK JP"/>
-        <a:ea typeface="Noto Sans CJK JP"/>
+        <a:latin typeface="BIZ UDPGothic"/>
+        <a:ea typeface="BIZ UDPGothic"/>
         <a:cs typeface=""/>
         <a:font script="Jpan" typeface="游ゴシック Light"/>
         <a:font script="Hang" typeface="맑은 고딕"/>
@@ -28506,8 +28558,8 @@
         <a:font script="Tfng" typeface="Ebrima"/>
       </a:majorFont>
       <a:minorFont>
-        <a:latin typeface="Noto Sans CJK JP"/>
-        <a:ea typeface="Noto Sans CJK JP"/>
+        <a:latin typeface="BIZ UDPGothic"/>
+        <a:ea typeface="BIZ UDPGothic"/>
         <a:cs typeface=""/>
         <a:font script="Jpan" typeface="游ゴシック"/>
         <a:font script="Hang" typeface="맑은 고딕"/>

</xml_diff>